<commit_message>
Adiciona o deck do processo, sem capturas de tela
Dez slides contando como o projeto foi construido, do requisito ao deploy,
com a demonstracao ao vivo no final. Sem imagens da loja de proposito: ela
e mostrada na hora, na URL de producao.

Alem das etapas, o deck traz os problemas encontrados e como foram
resolvidos — o teste que estava errado, os tres problemas que so apareceram
em producao e os oito achados do OWASP ZAP. Cada slide tem nota do
apresentador.

Ajusta tambem dois titulos que estourariam a caixa de texto, num e noutro
deck.

Co-Authored-By: Claude Opus 5 <noreply@anthropic.com>
</commit_message>
<xml_diff>
--- a/docs/Defesa_Torra_e_Terra.pptx
+++ b/docs/Defesa_Torra_e_Terra.pptx
@@ -3752,23 +3752,23 @@
         <p:spPr>
           <a:xfrm>
             <a:off x="566928" y="1920240"/>
-            <a:ext cx="7772400" cy="822960"/>
-          </a:xfrm>
-          <a:prstGeom prst="rect">
-            <a:avLst/>
-          </a:prstGeom>
-          <a:noFill/>
-          <a:ln/>
-        </p:spPr>
-        <p:txBody>
-          <a:bodyPr wrap="square" lIns="0" tIns="0" rIns="0" bIns="0" rtlCol="0" anchor="ctr"/>
-          <a:lstStyle/>
-          <a:p>
-            <a:pPr indent="0" marL="0">
-              <a:buNone/>
-            </a:pPr>
-            <a:r>
-              <a:rPr lang="en-US" sz="4000" dirty="0">
+            <a:ext cx="8229600" cy="914400"/>
+          </a:xfrm>
+          <a:prstGeom prst="rect">
+            <a:avLst/>
+          </a:prstGeom>
+          <a:noFill/>
+          <a:ln/>
+        </p:spPr>
+        <p:txBody>
+          <a:bodyPr wrap="square" lIns="0" tIns="0" rIns="0" bIns="0" rtlCol="0" anchor="ctr"/>
+          <a:lstStyle/>
+          <a:p>
+            <a:pPr indent="0" marL="0">
+              <a:buNone/>
+            </a:pPr>
+            <a:r>
+              <a:rPr lang="en-US" sz="3600" dirty="0">
                 <a:solidFill>
                   <a:srgbClr val="FFFFFF"/>
                 </a:solidFill>
@@ -3778,7 +3778,7 @@
               </a:rPr>
               <a:t>A lógica do projeto é cumulativa</a:t>
             </a:r>
-            <a:endParaRPr lang="en-US" sz="4000" dirty="0"/>
+            <a:endParaRPr lang="en-US" sz="3600" dirty="0"/>
           </a:p>
         </p:txBody>
       </p:sp>

</xml_diff>